<commit_message>
Document the public live dashboard on GitHub Pages
README explains the serverless operation and how to pull the live
database; papers and decks link the dashboard.
</commit_message>
<xml_diff>
--- a/presentation/Esenboga_Presentation_EN.pptx
+++ b/presentation/Esenboga_Presentation_EN.pptx
@@ -121,14 +121,14 @@
   <p:extLst>
     <p:ext uri="{521415D9-36F7-43E2-AB2F-B90AF26B5E84}">
       <p14:sectionLst xmlns:p14="http://schemas.microsoft.com/office/powerpoint/2010/main">
-        <p14:section name="Introduction" id="{f4a2f915-b05b-3852-ce1e-52fd341e5377}">
+        <p14:section name="Introduction" id="{3ef76fed-0790-05c4-c6d0-8be984ccd843}">
           <p14:sldIdLst>
             <p14:sldId id="256"/>
             <p14:sldId id="257"/>
             <p14:sldId id="258"/>
           </p14:sldIdLst>
         </p14:section>
-        <p14:section name="Data and method" id="{47dd2493-543a-3391-4c22-3bde58be94f0}">
+        <p14:section name="Data and method" id="{3d66c642-fece-4b15-d37d-2c371b1f02e0}">
           <p14:sldIdLst>
             <p14:sldId id="259"/>
             <p14:sldId id="260"/>
@@ -136,7 +136,7 @@
             <p14:sldId id="262"/>
           </p14:sldIdLst>
         </p14:section>
-        <p14:section name="Results" id="{8cc34f0d-3e1c-e073-598e-ce3227919f64}">
+        <p14:section name="Results" id="{c67e9586-fbe9-9eca-c348-2e8d7fdc88d8}">
           <p14:sldIdLst>
             <p14:sldId id="263"/>
             <p14:sldId id="264"/>
@@ -146,7 +146,7 @@
             <p14:sldId id="268"/>
           </p14:sldIdLst>
         </p14:section>
-        <p14:section name="Application and conclusion" id="{01a060f5-2ffc-b9b7-3a38-0eccfbd578c5}">
+        <p14:section name="Application and conclusion" id="{7d12b588-38b0-e8b1-a931-8484e651745c}">
           <p14:sldIdLst>
             <p14:sldId id="269"/>
             <p14:sldId id="270"/>
@@ -5945,7 +5945,7 @@
                   <a:schemeClr val="tx1"/>
                 </a:solidFill>
               </a:rPr>
-              <a:t>Open source: FastAPI + plain HTML/CSS/JS</a:t>
+              <a:t>Live page (GitHub Actions, every 30 min): atasakik.github.io/esenboga-fog-nowcasting</a:t>
             </a:r>
             <a:endParaRPr lang="en-US" sz="1700" dirty="0"/>
           </a:p>

</xml_diff>

<commit_message>
Redesign the dashboard in plain Turkish and apply code-review fixes
- New single-column dashboard for non-specialists: plain-language status,
  runway scene drawn from the observed visibility, hour-by-hour fog chance
  with warning thresholds, Turkey time, km/h and metres, glossary, and
  verification explained in words (technical tables kept behind details).
- SHAP values summed into ten plain-language factor groups (PLAIN_FACTORS).
- Shared live cycle (live_log.run_cycle) for the server, the static
  publisher and the CLI; refresh lock in the FastAPI server; verification
  limited to the fetched window; feature matrix built once per horizon.
- Workflow no longer overwrites the live log when the branch fetch fails.
- New test: every model feature belongs to one plain-language factor.
- Paper and decks updated with the new application figure.
</commit_message>
<xml_diff>
--- a/presentation/Esenboga_Presentation_EN.pptx
+++ b/presentation/Esenboga_Presentation_EN.pptx
@@ -121,14 +121,14 @@
   <p:extLst>
     <p:ext uri="{521415D9-36F7-43E2-AB2F-B90AF26B5E84}">
       <p14:sectionLst xmlns:p14="http://schemas.microsoft.com/office/powerpoint/2010/main">
-        <p14:section name="Introduction" id="{3ef76fed-0790-05c4-c6d0-8be984ccd843}">
+        <p14:section name="Introduction" id="{b1673e70-fed5-3534-ca95-1b957f41cb3f}">
           <p14:sldIdLst>
             <p14:sldId id="256"/>
             <p14:sldId id="257"/>
             <p14:sldId id="258"/>
           </p14:sldIdLst>
         </p14:section>
-        <p14:section name="Data and method" id="{3d66c642-fece-4b15-d37d-2c371b1f02e0}">
+        <p14:section name="Data and method" id="{4457916e-d5b3-57a6-cf01-4846ac0b024e}">
           <p14:sldIdLst>
             <p14:sldId id="259"/>
             <p14:sldId id="260"/>
@@ -136,7 +136,7 @@
             <p14:sldId id="262"/>
           </p14:sldIdLst>
         </p14:section>
-        <p14:section name="Results" id="{c67e9586-fbe9-9eca-c348-2e8d7fdc88d8}">
+        <p14:section name="Results" id="{c42be620-b811-e4f7-d093-05eaa68eaaef}">
           <p14:sldIdLst>
             <p14:sldId id="263"/>
             <p14:sldId id="264"/>
@@ -146,7 +146,7 @@
             <p14:sldId id="268"/>
           </p14:sldIdLst>
         </p14:section>
-        <p14:section name="Application and conclusion" id="{7d12b588-38b0-e8b1-a931-8484e651745c}">
+        <p14:section name="Application and conclusion" id="{1d1f0d3b-54ae-1312-402e-b6994f85a122}">
           <p14:sldIdLst>
             <p14:sldId id="269"/>
             <p14:sldId id="270"/>
@@ -5891,7 +5891,7 @@
                   <a:schemeClr val="tx1"/>
                 </a:solidFill>
               </a:rPr>
-              <a:t>SHAP-based driving factors for every forecast</a:t>
+              <a:t>SHAP-based driving factors in plain language</a:t>
             </a:r>
             <a:endParaRPr lang="en-US" sz="1700" dirty="0"/>
           </a:p>

</xml_diff>